<commit_message>
Diaporama nouveaux programmes : liens cliquables vers programme.teckno.fr
- PowerPoint : liens hypertextes sur les diapositives 35, 36 et 37
- Visionneuse : zones cliquables sur les liens de la diapositive et bouton de lien dans la barre

Co-Authored-By: Claude Opus 5.5 <noreply@anthropic.com>
Claude-Session: https://claude.ai/code/session_015LmYfYcPh4LZhnreWb3a4Q
</commit_message>
<xml_diff>
--- a/formation/nouveaux-programmes/nouveau_programme_technologie_cycle4_2026-2027.pptx
+++ b/formation/nouveaux-programmes/nouveau_programme_technologie_cycle4_2026-2027.pptx
@@ -144,14 +144,14 @@
   <p:extLst>
     <p:ext uri="{521415D9-36F7-43E2-AB2F-B90AF26B5E84}">
       <p14:sectionLst xmlns:p14="http://schemas.microsoft.com/office/powerpoint/2010/main">
-        <p14:section name="Ouverture" id="{c8b8f836-db3f-dafd-2586-a5ccee425ef4}">
+        <p14:section name="Ouverture" id="{ea4556dd-0830-5f5c-11dd-d3476b5d71e1}">
           <p14:sldIdLst>
             <p14:sldId id="256"/>
             <p14:sldId id="257"/>
             <p14:sldId id="258"/>
           </p14:sldIdLst>
         </p14:section>
-        <p14:section name="Le cadre" id="{22d1cd48-f6b8-7a5b-7755-13c9e42433c5}">
+        <p14:section name="Le cadre" id="{0174c573-3d6f-4d69-e7a1-3ed322e84191}">
           <p14:sldIdLst>
             <p14:sldId id="259"/>
             <p14:sldId id="260"/>
@@ -160,7 +160,7 @@
             <p14:sldId id="263"/>
           </p14:sldIdLst>
         </p14:section>
-        <p14:section name="Le programme" id="{23e3108e-6dd2-42d2-e5f1-f45d2f621921}">
+        <p14:section name="Le programme" id="{58b255a2-19a9-2448-7f5c-46dc38ed6dc5}">
           <p14:sldIdLst>
             <p14:sldId id="264"/>
             <p14:sldId id="265"/>
@@ -171,7 +171,7 @@
             <p14:sldId id="270"/>
           </p14:sldIdLst>
         </p14:section>
-        <p14:section name="Ce qui change" id="{5a44829e-f13b-b743-14d7-f43705e210bd}">
+        <p14:section name="Ce qui change" id="{b62286c8-63c7-d77b-e4fa-5d0c4c2d8fc9}">
           <p14:sldIdLst>
             <p14:sldId id="271"/>
             <p14:sldId id="272"/>
@@ -180,7 +180,7 @@
             <p14:sldId id="275"/>
           </p14:sldIdLst>
         </p14:section>
-        <p14:section name="Enseigner" id="{5698d0ac-2487-4663-a577-d652bd4c30ec}">
+        <p14:section name="Enseigner" id="{4d2bc5e2-2b23-b099-8a9a-e06685b58afc}">
           <p14:sldIdLst>
             <p14:sldId id="276"/>
             <p14:sldId id="277"/>
@@ -190,7 +190,7 @@
             <p14:sldId id="281"/>
           </p14:sldIdLst>
         </p14:section>
-        <p14:section name="DNB 2027" id="{6dc03cd2-fe75-b40b-4f41-1da14a1c420a}">
+        <p14:section name="DNB 2027" id="{3f183e73-efe7-f35c-ecf8-6526b34fccaf}">
           <p14:sldIdLst>
             <p14:sldId id="282"/>
             <p14:sldId id="283"/>
@@ -201,7 +201,7 @@
             <p14:sldId id="288"/>
           </p14:sldIdLst>
         </p14:section>
-        <p14:section name="Ressources et formation" id="{1a15e7d4-9c6d-92b3-79e9-1d9988045d2d}">
+        <p14:section name="Ressources et formation" id="{0bd77d0c-bfe4-65ea-32f5-fc83b264f44a}">
           <p14:sldIdLst>
             <p14:sldId id="289"/>
             <p14:sldId id="290"/>
@@ -30021,7 +30021,80 @@
       </p:sp>
       <p:sp>
         <p:nvSpPr>
-          <p:cNvPr id="4" name="Carte Le programme et le DNB"/>
+          <p:cNvPr id="4" name="Lien programme.teckno.fr"/>
+          <p:cNvSpPr/>
+          <p:nvPr/>
+        </p:nvSpPr>
+        <p:spPr>
+          <a:xfrm>
+            <a:off x="6446520" y="237744"/>
+            <a:ext cx="2240280" cy="329184"/>
+          </a:xfrm>
+          <a:prstGeom prst="roundRect">
+            <a:avLst>
+              <a:gd name="adj" fmla="val 33333"/>
+            </a:avLst>
+          </a:prstGeom>
+          <a:solidFill>
+            <a:srgbClr val="C2185B"/>
+          </a:solidFill>
+          <a:ln w="12700">
+            <a:solidFill>
+              <a:srgbClr val="C2185B"/>
+            </a:solidFill>
+            <a:prstDash val="solid"/>
+          </a:ln>
+        </p:spPr>
+      </p:sp>
+      <p:sp>
+        <p:nvSpPr>
+          <p:cNvPr id="5" name="Text 3"/>
+          <p:cNvSpPr txBox="1"/>
+          <p:nvPr/>
+        </p:nvSpPr>
+        <p:spPr>
+          <a:xfrm>
+            <a:off x="6446520" y="237744"/>
+            <a:ext cx="2240280" cy="329184"/>
+          </a:xfrm>
+          <a:prstGeom prst="rect">
+            <a:avLst/>
+          </a:prstGeom>
+          <a:noFill/>
+          <a:ln/>
+        </p:spPr>
+        <p:txBody>
+          <a:bodyPr wrap="square" lIns="0" tIns="0" rIns="0" bIns="0" rtlCol="0" anchor="ctr"/>
+          <a:lstStyle/>
+          <a:p>
+            <a:pPr algn="ctr" indent="0" marL="0">
+              <a:buNone/>
+            </a:pPr>
+            <a:r>
+              <a:rPr lang="en-US" sz="1200" b="1" u="sng" dirty="0">
+                <a:solidFill>
+                  <a:srgbClr val="FFFFFF"/>
+                </a:solidFill>
+                <a:latin typeface="Calibri" pitchFamily="34" charset="0"/>
+                <a:ea typeface="Calibri" pitchFamily="34" charset="-122"/>
+                <a:cs typeface="Calibri" pitchFamily="34" charset="-120"/>
+                <a:hlinkClick r:id="rId1" invalidUrl="" action="" tgtFrame="" tooltip="Ouvrir programme.teckno.fr" history="1" highlightClick="0" endSnd="0">
+                  <a:extLst>
+                    <a:ext uri="{A12FA001-AC4F-418D-AE19-62706E023703}">
+                      <ahyp:hlinkClr xmlns:ahyp="http://schemas.microsoft.com/office/drawing/2018/hyperlinkcolor" val="tx"/>
+                    </a:ext>
+                  </a:extLst>
+                </a:hlinkClick>
+              </a:rPr>
+              <a:t>programme.teckno.fr ↗</a:t>
+            </a:r>
+            <a:endParaRPr lang="en-US" sz="1200" dirty="0"/>
+          </a:p>
+        </p:txBody>
+      </p:sp>
+      <p:sp>
+        <p:nvSpPr>
+          <p:cNvPr id="6" name="Carte Le programme et le DNB"/>
           <p:cNvSpPr/>
           <p:nvPr/>
         </p:nvSpPr>
@@ -30048,7 +30121,7 @@
       </p:sp>
       <p:sp>
         <p:nvSpPr>
-          <p:cNvPr id="5" name="Repère 0"/>
+          <p:cNvPr id="7" name="Repère 0"/>
           <p:cNvSpPr/>
           <p:nvPr/>
         </p:nvSpPr>
@@ -30073,7 +30146,7 @@
       </p:sp>
       <p:sp>
         <p:nvSpPr>
-          <p:cNvPr id="6" name="Text 4"/>
+          <p:cNvPr id="8" name="Text 6"/>
           <p:cNvSpPr txBox="1"/>
           <p:nvPr/>
         </p:nvSpPr>
@@ -30112,7 +30185,7 @@
       </p:sp>
       <p:sp>
         <p:nvSpPr>
-          <p:cNvPr id="7" name="Text 5"/>
+          <p:cNvPr id="9" name="Text 7"/>
           <p:cNvSpPr txBox="1"/>
           <p:nvPr/>
         </p:nvSpPr>
@@ -30151,7 +30224,7 @@
       </p:sp>
       <p:sp>
         <p:nvSpPr>
-          <p:cNvPr id="8" name="Text 6"/>
+          <p:cNvPr id="10" name="Text 8"/>
           <p:cNvSpPr txBox="1"/>
           <p:nvPr/>
         </p:nvSpPr>
@@ -30190,7 +30263,7 @@
       </p:sp>
       <p:sp>
         <p:nvSpPr>
-          <p:cNvPr id="9" name="Carte Accompagnement du programme"/>
+          <p:cNvPr id="11" name="Carte Accompagnement du programme"/>
           <p:cNvSpPr/>
           <p:nvPr/>
         </p:nvSpPr>
@@ -30217,7 +30290,7 @@
       </p:sp>
       <p:sp>
         <p:nvSpPr>
-          <p:cNvPr id="10" name="Repère 1"/>
+          <p:cNvPr id="12" name="Repère 1"/>
           <p:cNvSpPr/>
           <p:nvPr/>
         </p:nvSpPr>
@@ -30242,7 +30315,7 @@
       </p:sp>
       <p:sp>
         <p:nvSpPr>
-          <p:cNvPr id="11" name="Text 9"/>
+          <p:cNvPr id="13" name="Text 11"/>
           <p:cNvSpPr txBox="1"/>
           <p:nvPr/>
         </p:nvSpPr>
@@ -30281,7 +30354,7 @@
       </p:sp>
       <p:sp>
         <p:nvSpPr>
-          <p:cNvPr id="12" name="Text 10"/>
+          <p:cNvPr id="14" name="Text 12"/>
           <p:cNvSpPr txBox="1"/>
           <p:nvPr/>
         </p:nvSpPr>
@@ -30320,7 +30393,7 @@
       </p:sp>
       <p:sp>
         <p:nvSpPr>
-          <p:cNvPr id="13" name="Text 11"/>
+          <p:cNvPr id="15" name="Text 13"/>
           <p:cNvSpPr txBox="1"/>
           <p:nvPr/>
         </p:nvSpPr>
@@ -30359,7 +30432,7 @@
       </p:sp>
       <p:sp>
         <p:nvSpPr>
-          <p:cNvPr id="14" name="Carte Banques de séquences"/>
+          <p:cNvPr id="16" name="Carte Banques de séquences"/>
           <p:cNvSpPr/>
           <p:nvPr/>
         </p:nvSpPr>
@@ -30386,7 +30459,7 @@
       </p:sp>
       <p:sp>
         <p:nvSpPr>
-          <p:cNvPr id="15" name="Repère 2"/>
+          <p:cNvPr id="17" name="Repère 2"/>
           <p:cNvSpPr/>
           <p:nvPr/>
         </p:nvSpPr>
@@ -30411,7 +30484,7 @@
       </p:sp>
       <p:sp>
         <p:nvSpPr>
-          <p:cNvPr id="16" name="Text 14"/>
+          <p:cNvPr id="18" name="Text 16"/>
           <p:cNvSpPr txBox="1"/>
           <p:nvPr/>
         </p:nvSpPr>
@@ -30450,7 +30523,7 @@
       </p:sp>
       <p:sp>
         <p:nvSpPr>
-          <p:cNvPr id="17" name="Text 15"/>
+          <p:cNvPr id="19" name="Text 17"/>
           <p:cNvSpPr txBox="1"/>
           <p:nvPr/>
         </p:nvSpPr>
@@ -30489,7 +30562,7 @@
       </p:sp>
       <p:sp>
         <p:nvSpPr>
-          <p:cNvPr id="18" name="Text 16"/>
+          <p:cNvPr id="20" name="Text 18"/>
           <p:cNvSpPr txBox="1"/>
           <p:nvPr/>
         </p:nvSpPr>
@@ -30528,7 +30601,7 @@
       </p:sp>
       <p:sp>
         <p:nvSpPr>
-          <p:cNvPr id="19" name="Carte programme.teckno.fr et le site de formation"/>
+          <p:cNvPr id="21" name="Carte programme.teckno.fr et le site de formation"/>
           <p:cNvSpPr/>
           <p:nvPr/>
         </p:nvSpPr>
@@ -30555,7 +30628,7 @@
       </p:sp>
       <p:sp>
         <p:nvSpPr>
-          <p:cNvPr id="20" name="Repère 3"/>
+          <p:cNvPr id="22" name="Repère 3"/>
           <p:cNvSpPr/>
           <p:nvPr/>
         </p:nvSpPr>
@@ -30580,7 +30653,7 @@
       </p:sp>
       <p:sp>
         <p:nvSpPr>
-          <p:cNvPr id="21" name="Text 19"/>
+          <p:cNvPr id="23" name="Text 21"/>
           <p:cNvSpPr txBox="1"/>
           <p:nvPr/>
         </p:nvSpPr>
@@ -30619,7 +30692,7 @@
       </p:sp>
       <p:sp>
         <p:nvSpPr>
-          <p:cNvPr id="22" name="Text 20"/>
+          <p:cNvPr id="24" name="Text 22"/>
           <p:cNvSpPr txBox="1"/>
           <p:nvPr/>
         </p:nvSpPr>
@@ -30658,7 +30731,7 @@
       </p:sp>
       <p:sp>
         <p:nvSpPr>
-          <p:cNvPr id="23" name="Text 21"/>
+          <p:cNvPr id="25" name="Text 23"/>
           <p:cNvSpPr txBox="1"/>
           <p:nvPr/>
         </p:nvSpPr>
@@ -30797,7 +30870,7 @@
                   <a:srgbClr val="0E6E6B"/>
                 </a:solidFill>
               </a:rPr>
-              <a:t>UN PORTAIL POUR PRÉPARER SES COURS · PROGRAMME.TECKNO.FR</a:t>
+              <a:t>UN PORTAIL POUR PRÉPARER SES COURS</a:t>
             </a:r>
             <a:endParaRPr lang="en-US" sz="1100" dirty="0"/>
           </a:p>
@@ -31899,7 +31972,7 @@
       </p:sp>
       <p:sp>
         <p:nvSpPr>
-          <p:cNvPr id="35" name="Bandeau"/>
+          <p:cNvPr id="35" name="Bandeau portail"/>
           <p:cNvSpPr/>
           <p:nvPr/>
         </p:nvSpPr>
@@ -31957,9 +32030,117 @@
                 <a:ea typeface="Calibri" pitchFamily="34" charset="-122"/>
                 <a:cs typeface="Calibri" pitchFamily="34" charset="-120"/>
               </a:rPr>
-              <a:t>Et aussi : les 9 compétences cliquables, une page de didactique, les sources officielles.</a:t>
+              <a:t>Ouvrir le portail : </a:t>
+            </a:r>
+            <a:pPr indent="0" marL="0">
+              <a:buNone/>
+            </a:pPr>
+            <a:r>
+              <a:rPr lang="en-US" sz="1250" b="1" u="sng" dirty="0">
+                <a:solidFill>
+                  <a:srgbClr val="C2185B"/>
+                </a:solidFill>
+                <a:latin typeface="Calibri" pitchFamily="34" charset="0"/>
+                <a:ea typeface="Calibri" pitchFamily="34" charset="-122"/>
+                <a:cs typeface="Calibri" pitchFamily="34" charset="-120"/>
+                <a:hlinkClick r:id="rId1" invalidUrl="" action="" tgtFrame="" tooltip="Ouvrir programme.teckno.fr" history="1" highlightClick="0" endSnd="0">
+                  <a:extLst>
+                    <a:ext uri="{A12FA001-AC4F-418D-AE19-62706E023703}">
+                      <ahyp:hlinkClr xmlns:ahyp="http://schemas.microsoft.com/office/drawing/2018/hyperlinkcolor" val="tx"/>
+                    </a:ext>
+                  </a:extLst>
+                </a:hlinkClick>
+              </a:rPr>
+              <a:t>programme.teckno.fr</a:t>
+            </a:r>
+            <a:pPr indent="0" marL="0">
+              <a:buNone/>
+            </a:pPr>
+            <a:r>
+              <a:rPr lang="en-US" sz="1250" dirty="0">
+                <a:solidFill>
+                  <a:srgbClr val="0A5A58"/>
+                </a:solidFill>
+                <a:latin typeface="Calibri" pitchFamily="34" charset="0"/>
+                <a:ea typeface="Calibri" pitchFamily="34" charset="-122"/>
+                <a:cs typeface="Calibri" pitchFamily="34" charset="-120"/>
+              </a:rPr>
+              <a:t>   ·   9 compétences cliquables, didactique, sources officielles</a:t>
             </a:r>
             <a:endParaRPr lang="en-US" sz="1250" dirty="0"/>
+          </a:p>
+        </p:txBody>
+      </p:sp>
+      <p:sp>
+        <p:nvSpPr>
+          <p:cNvPr id="37" name="Lien programme.teckno.fr"/>
+          <p:cNvSpPr/>
+          <p:nvPr/>
+        </p:nvSpPr>
+        <p:spPr>
+          <a:xfrm>
+            <a:off x="6446520" y="237744"/>
+            <a:ext cx="2240280" cy="329184"/>
+          </a:xfrm>
+          <a:prstGeom prst="roundRect">
+            <a:avLst>
+              <a:gd name="adj" fmla="val 33333"/>
+            </a:avLst>
+          </a:prstGeom>
+          <a:solidFill>
+            <a:srgbClr val="C2185B"/>
+          </a:solidFill>
+          <a:ln w="12700">
+            <a:solidFill>
+              <a:srgbClr val="C2185B"/>
+            </a:solidFill>
+            <a:prstDash val="solid"/>
+          </a:ln>
+        </p:spPr>
+      </p:sp>
+      <p:sp>
+        <p:nvSpPr>
+          <p:cNvPr id="38" name="Text 36"/>
+          <p:cNvSpPr txBox="1"/>
+          <p:nvPr/>
+        </p:nvSpPr>
+        <p:spPr>
+          <a:xfrm>
+            <a:off x="6446520" y="237744"/>
+            <a:ext cx="2240280" cy="329184"/>
+          </a:xfrm>
+          <a:prstGeom prst="rect">
+            <a:avLst/>
+          </a:prstGeom>
+          <a:noFill/>
+          <a:ln/>
+        </p:spPr>
+        <p:txBody>
+          <a:bodyPr wrap="square" lIns="0" tIns="0" rIns="0" bIns="0" rtlCol="0" anchor="ctr"/>
+          <a:lstStyle/>
+          <a:p>
+            <a:pPr algn="ctr" indent="0" marL="0">
+              <a:buNone/>
+            </a:pPr>
+            <a:r>
+              <a:rPr lang="en-US" sz="1200" b="1" u="sng" dirty="0">
+                <a:solidFill>
+                  <a:srgbClr val="FFFFFF"/>
+                </a:solidFill>
+                <a:latin typeface="Calibri" pitchFamily="34" charset="0"/>
+                <a:ea typeface="Calibri" pitchFamily="34" charset="-122"/>
+                <a:cs typeface="Calibri" pitchFamily="34" charset="-120"/>
+                <a:hlinkClick r:id="rId2" invalidUrl="" action="" tgtFrame="" tooltip="Ouvrir programme.teckno.fr" history="1" highlightClick="0" endSnd="0">
+                  <a:extLst>
+                    <a:ext uri="{A12FA001-AC4F-418D-AE19-62706E023703}">
+                      <ahyp:hlinkClr xmlns:ahyp="http://schemas.microsoft.com/office/drawing/2018/hyperlinkcolor" val="tx"/>
+                    </a:ext>
+                  </a:extLst>
+                </a:hlinkClick>
+              </a:rPr>
+              <a:t>programme.teckno.fr ↗</a:t>
+            </a:r>
+            <a:endParaRPr lang="en-US" sz="1200" dirty="0"/>
           </a:p>
         </p:txBody>
       </p:sp>
@@ -32114,7 +32295,80 @@
       </p:sp>
       <p:sp>
         <p:nvSpPr>
-          <p:cNvPr id="4" name="Stat 0"/>
+          <p:cNvPr id="4" name="Lien Ouvrir le moteur"/>
+          <p:cNvSpPr/>
+          <p:nvPr/>
+        </p:nvSpPr>
+        <p:spPr>
+          <a:xfrm>
+            <a:off x="6446520" y="237744"/>
+            <a:ext cx="2240280" cy="329184"/>
+          </a:xfrm>
+          <a:prstGeom prst="roundRect">
+            <a:avLst>
+              <a:gd name="adj" fmla="val 33333"/>
+            </a:avLst>
+          </a:prstGeom>
+          <a:solidFill>
+            <a:srgbClr val="C2185B"/>
+          </a:solidFill>
+          <a:ln w="12700">
+            <a:solidFill>
+              <a:srgbClr val="C2185B"/>
+            </a:solidFill>
+            <a:prstDash val="solid"/>
+          </a:ln>
+        </p:spPr>
+      </p:sp>
+      <p:sp>
+        <p:nvSpPr>
+          <p:cNvPr id="5" name="Text 3"/>
+          <p:cNvSpPr txBox="1"/>
+          <p:nvPr/>
+        </p:nvSpPr>
+        <p:spPr>
+          <a:xfrm>
+            <a:off x="6446520" y="237744"/>
+            <a:ext cx="2240280" cy="329184"/>
+          </a:xfrm>
+          <a:prstGeom prst="rect">
+            <a:avLst/>
+          </a:prstGeom>
+          <a:noFill/>
+          <a:ln/>
+        </p:spPr>
+        <p:txBody>
+          <a:bodyPr wrap="square" lIns="0" tIns="0" rIns="0" bIns="0" rtlCol="0" anchor="ctr"/>
+          <a:lstStyle/>
+          <a:p>
+            <a:pPr algn="ctr" indent="0" marL="0">
+              <a:buNone/>
+            </a:pPr>
+            <a:r>
+              <a:rPr lang="en-US" sz="1200" b="1" u="sng" dirty="0">
+                <a:solidFill>
+                  <a:srgbClr val="FFFFFF"/>
+                </a:solidFill>
+                <a:latin typeface="Calibri" pitchFamily="34" charset="0"/>
+                <a:ea typeface="Calibri" pitchFamily="34" charset="-122"/>
+                <a:cs typeface="Calibri" pitchFamily="34" charset="-120"/>
+                <a:hlinkClick r:id="rId1" invalidUrl="" action="" tgtFrame="" tooltip="Ouvrir Ouvrir le moteur" history="1" highlightClick="0" endSnd="0">
+                  <a:extLst>
+                    <a:ext uri="{A12FA001-AC4F-418D-AE19-62706E023703}">
+                      <ahyp:hlinkClr xmlns:ahyp="http://schemas.microsoft.com/office/drawing/2018/hyperlinkcolor" val="tx"/>
+                    </a:ext>
+                  </a:extLst>
+                </a:hlinkClick>
+              </a:rPr>
+              <a:t>Ouvrir le moteur ↗</a:t>
+            </a:r>
+            <a:endParaRPr lang="en-US" sz="1200" dirty="0"/>
+          </a:p>
+        </p:txBody>
+      </p:sp>
+      <p:sp>
+        <p:nvSpPr>
+          <p:cNvPr id="6" name="Stat 0"/>
           <p:cNvSpPr/>
           <p:nvPr/>
         </p:nvSpPr>
@@ -32141,7 +32395,7 @@
       </p:sp>
       <p:sp>
         <p:nvSpPr>
-          <p:cNvPr id="5" name="Text 3"/>
+          <p:cNvPr id="7" name="Text 5"/>
           <p:cNvSpPr txBox="1"/>
           <p:nvPr/>
         </p:nvSpPr>
@@ -32180,7 +32434,7 @@
       </p:sp>
       <p:sp>
         <p:nvSpPr>
-          <p:cNvPr id="6" name="Text 4"/>
+          <p:cNvPr id="8" name="Text 6"/>
           <p:cNvSpPr txBox="1"/>
           <p:nvPr/>
         </p:nvSpPr>
@@ -32219,7 +32473,7 @@
       </p:sp>
       <p:sp>
         <p:nvSpPr>
-          <p:cNvPr id="7" name="Stat 1"/>
+          <p:cNvPr id="9" name="Stat 1"/>
           <p:cNvSpPr/>
           <p:nvPr/>
         </p:nvSpPr>
@@ -32246,7 +32500,7 @@
       </p:sp>
       <p:sp>
         <p:nvSpPr>
-          <p:cNvPr id="8" name="Text 6"/>
+          <p:cNvPr id="10" name="Text 8"/>
           <p:cNvSpPr txBox="1"/>
           <p:nvPr/>
         </p:nvSpPr>
@@ -32285,7 +32539,7 @@
       </p:sp>
       <p:sp>
         <p:nvSpPr>
-          <p:cNvPr id="9" name="Text 7"/>
+          <p:cNvPr id="11" name="Text 9"/>
           <p:cNvSpPr txBox="1"/>
           <p:nvPr/>
         </p:nvSpPr>
@@ -32324,7 +32578,7 @@
       </p:sp>
       <p:sp>
         <p:nvSpPr>
-          <p:cNvPr id="10" name="Stat 2"/>
+          <p:cNvPr id="12" name="Stat 2"/>
           <p:cNvSpPr/>
           <p:nvPr/>
         </p:nvSpPr>
@@ -32351,7 +32605,7 @@
       </p:sp>
       <p:sp>
         <p:nvSpPr>
-          <p:cNvPr id="11" name="Text 9"/>
+          <p:cNvPr id="13" name="Text 11"/>
           <p:cNvSpPr txBox="1"/>
           <p:nvPr/>
         </p:nvSpPr>
@@ -32390,7 +32644,7 @@
       </p:sp>
       <p:sp>
         <p:nvSpPr>
-          <p:cNvPr id="12" name="Text 10"/>
+          <p:cNvPr id="14" name="Text 12"/>
           <p:cNvSpPr txBox="1"/>
           <p:nvPr/>
         </p:nvSpPr>
@@ -32429,7 +32683,7 @@
       </p:sp>
       <p:sp>
         <p:nvSpPr>
-          <p:cNvPr id="13" name="Stat 3"/>
+          <p:cNvPr id="15" name="Stat 3"/>
           <p:cNvSpPr/>
           <p:nvPr/>
         </p:nvSpPr>
@@ -32456,7 +32710,7 @@
       </p:sp>
       <p:sp>
         <p:nvSpPr>
-          <p:cNvPr id="14" name="Text 12"/>
+          <p:cNvPr id="16" name="Text 14"/>
           <p:cNvSpPr txBox="1"/>
           <p:nvPr/>
         </p:nvSpPr>
@@ -32495,7 +32749,7 @@
       </p:sp>
       <p:sp>
         <p:nvSpPr>
-          <p:cNvPr id="15" name="Text 13"/>
+          <p:cNvPr id="17" name="Text 15"/>
           <p:cNvSpPr txBox="1"/>
           <p:nvPr/>
         </p:nvSpPr>
@@ -32534,7 +32788,7 @@
       </p:sp>
       <p:sp>
         <p:nvSpPr>
-          <p:cNvPr id="16" name="Carte Chercher par notion"/>
+          <p:cNvPr id="18" name="Carte Chercher par notion"/>
           <p:cNvSpPr/>
           <p:nvPr/>
         </p:nvSpPr>
@@ -32561,7 +32815,7 @@
       </p:sp>
       <p:sp>
         <p:nvSpPr>
-          <p:cNvPr id="17" name="Repère 0"/>
+          <p:cNvPr id="19" name="Repère 0"/>
           <p:cNvSpPr/>
           <p:nvPr/>
         </p:nvSpPr>
@@ -32586,7 +32840,7 @@
       </p:sp>
       <p:sp>
         <p:nvSpPr>
-          <p:cNvPr id="18" name="Text 16"/>
+          <p:cNvPr id="20" name="Text 18"/>
           <p:cNvSpPr txBox="1"/>
           <p:nvPr/>
         </p:nvSpPr>
@@ -32625,7 +32879,7 @@
       </p:sp>
       <p:sp>
         <p:nvSpPr>
-          <p:cNvPr id="19" name="Text 17"/>
+          <p:cNvPr id="21" name="Text 19"/>
           <p:cNvSpPr txBox="1"/>
           <p:nvPr/>
         </p:nvSpPr>
@@ -32664,7 +32918,7 @@
       </p:sp>
       <p:sp>
         <p:nvSpPr>
-          <p:cNvPr id="20" name="Carte Filtrer"/>
+          <p:cNvPr id="22" name="Carte Filtrer"/>
           <p:cNvSpPr/>
           <p:nvPr/>
         </p:nvSpPr>
@@ -32691,7 +32945,7 @@
       </p:sp>
       <p:sp>
         <p:nvSpPr>
-          <p:cNvPr id="21" name="Repère 1"/>
+          <p:cNvPr id="23" name="Repère 1"/>
           <p:cNvSpPr/>
           <p:nvPr/>
         </p:nvSpPr>
@@ -32716,7 +32970,7 @@
       </p:sp>
       <p:sp>
         <p:nvSpPr>
-          <p:cNvPr id="22" name="Text 20"/>
+          <p:cNvPr id="24" name="Text 22"/>
           <p:cNvSpPr txBox="1"/>
           <p:nvPr/>
         </p:nvSpPr>
@@ -32755,7 +33009,7 @@
       </p:sp>
       <p:sp>
         <p:nvSpPr>
-          <p:cNvPr id="23" name="Text 21"/>
+          <p:cNvPr id="25" name="Text 23"/>
           <p:cNvSpPr txBox="1"/>
           <p:nvPr/>
         </p:nvSpPr>
@@ -32794,7 +33048,7 @@
       </p:sp>
       <p:sp>
         <p:nvSpPr>
-          <p:cNvPr id="24" name="Carte Remonter à la source"/>
+          <p:cNvPr id="26" name="Carte Remonter à la source"/>
           <p:cNvSpPr/>
           <p:nvPr/>
         </p:nvSpPr>
@@ -32821,7 +33075,7 @@
       </p:sp>
       <p:sp>
         <p:nvSpPr>
-          <p:cNvPr id="25" name="Repère 2"/>
+          <p:cNvPr id="27" name="Repère 2"/>
           <p:cNvSpPr/>
           <p:nvPr/>
         </p:nvSpPr>
@@ -32846,7 +33100,7 @@
       </p:sp>
       <p:sp>
         <p:nvSpPr>
-          <p:cNvPr id="26" name="Text 24"/>
+          <p:cNvPr id="28" name="Text 26"/>
           <p:cNvSpPr txBox="1"/>
           <p:nvPr/>
         </p:nvSpPr>
@@ -32885,7 +33139,7 @@
       </p:sp>
       <p:sp>
         <p:nvSpPr>
-          <p:cNvPr id="27" name="Text 25"/>
+          <p:cNvPr id="29" name="Text 27"/>
           <p:cNvSpPr txBox="1"/>
           <p:nvPr/>
         </p:nvSpPr>
@@ -32924,7 +33178,7 @@
       </p:sp>
       <p:sp>
         <p:nvSpPr>
-          <p:cNvPr id="28" name="Veille"/>
+          <p:cNvPr id="30" name="Veille"/>
           <p:cNvSpPr/>
           <p:nvPr/>
         </p:nvSpPr>
@@ -32951,7 +33205,7 @@
       </p:sp>
       <p:sp>
         <p:nvSpPr>
-          <p:cNvPr id="29" name="Text 27"/>
+          <p:cNvPr id="31" name="Text 29"/>
           <p:cNvSpPr txBox="1"/>
           <p:nvPr/>
         </p:nvSpPr>

</xml_diff>